<commit_message>
feat: Upgrade InfraMind to Version 2 real-time cloud security platform
</commit_message>
<xml_diff>
--- a/presentation/InfraMind_Pitch_Deck.pptx
+++ b/presentation/InfraMind_Pitch_Deck.pptx
@@ -3458,7 +3458,7 @@
               </a:defRPr>
             </a:pPr>
             <a:r>
-              <a:t>Interactive Threat Cards</a:t>
+              <a:t>Live Telemetry &amp; Auto-Refresh</a:t>
             </a:r>
           </a:p>
           <a:p>
@@ -3470,7 +3470,7 @@
               </a:defRPr>
             </a:pPr>
             <a:r>
-              <a:t>One-click 'Analyze Alert via AMD GPU' displays risk summaries, blast radius, and target resource bindings.</a:t>
+              <a:t>Monitors SQS queue depth, worker heartbeat, and auto-refreshes threat cards every 10 seconds.</a:t>
             </a:r>
           </a:p>
         </p:txBody>
@@ -4395,7 +4395,7 @@
               </a:defRPr>
             </a:pPr>
             <a:r>
-              <a:t>Verified Quality Assurance</a:t>
+              <a:t>Comprehensive Verification</a:t>
             </a:r>
           </a:p>
           <a:p>
@@ -4407,7 +4407,7 @@
               </a:defRPr>
             </a:pPr>
             <a:r>
-              <a:t>50 automated unit tests passing with 100% coverage across input validation, LLM analysis, and safety gates.</a:t>
+              <a:t>63 automated unit tests passing with 100% success across remediation, agent, database, and ingestion.</a:t>
             </a:r>
           </a:p>
         </p:txBody>
@@ -4464,7 +4464,7 @@
               </a:defRPr>
             </a:pPr>
             <a:r>
-              <a:t>Future Expansion Roadmap</a:t>
+              <a:t>Production CloudFormation</a:t>
             </a:r>
           </a:p>
           <a:p>
@@ -4476,7 +4476,7 @@
               </a:defRPr>
             </a:pPr>
             <a:r>
-              <a:t>Multi-cloud coverage (Azure Blob &amp; Google Cloud IAM), Slack/Teams approval bots, and real-time CloudWatch streaming.</a:t>
+              <a:t>Ready-to-deploy infra/cloudformation-realtime.yaml provisioning SQS, DLQ, and EventBridge rules.</a:t>
             </a:r>
           </a:p>
         </p:txBody>
@@ -5901,7 +5901,7 @@
               </a:defRPr>
             </a:pPr>
             <a:r>
-              <a:t>Multi-Tier System Architecture</a:t>
+              <a:t>Version 2: Real-Time Pipeline Architecture</a:t>
             </a:r>
           </a:p>
         </p:txBody>
@@ -5936,7 +5936,7 @@
               </a:defRPr>
             </a:pPr>
             <a:r>
-              <a:t>End-to-end data pipeline with human-in-the-loop safeguards</a:t>
+              <a:t>Event-driven CloudTrail &amp; EventBridge ingestion with persistent SQLite WAL storage</a:t>
             </a:r>
           </a:p>
         </p:txBody>
@@ -5993,7 +5993,7 @@
               </a:defRPr>
             </a:pPr>
             <a:r>
-              <a:t>Tier 1: Telemetry Ingestion</a:t>
+              <a:t>Tier 1: Event Telemetry &amp; SQS</a:t>
             </a:r>
           </a:p>
           <a:p>
@@ -6005,7 +6005,7 @@
               </a:defRPr>
             </a:pPr>
             <a:r>
-              <a:t>Ingests AWS CloudTrail and event telemetry from mock_logs.json or live custom log feeds.</a:t>
+              <a:t>CloudTrail &amp; GuardDuty stream via EventBridge to SQS with Dead-Letter Queue (DLQ) buffering.</a:t>
             </a:r>
           </a:p>
         </p:txBody>
@@ -6062,7 +6062,7 @@
               </a:defRPr>
             </a:pPr>
             <a:r>
-              <a:t>Tier 2: AI Analysis Engine (agent.py)</a:t>
+              <a:t>Tier 2: Ingestion Worker (ingestion_worker.py)</a:t>
             </a:r>
           </a:p>
           <a:p>
@@ -6074,7 +6074,7 @@
               </a:defRPr>
             </a:pPr>
             <a:r>
-              <a:t>Connects to AMD Instinct GPU endpoints running ROCm vLLM or switches to deterministic fallback.</a:t>
+              <a:t>Long-polling worker normalizes events, checks S3 live posture, and persists atomically to SQLite.</a:t>
             </a:r>
           </a:p>
         </p:txBody>
@@ -6131,7 +6131,7 @@
               </a:defRPr>
             </a:pPr>
             <a:r>
-              <a:t>Tier 3: Operator Console (app.py)</a:t>
+              <a:t>Tier 3: AI Threat Engine (agent.py)</a:t>
             </a:r>
           </a:p>
           <a:p>
@@ -6143,7 +6143,7 @@
               </a:defRPr>
             </a:pPr>
             <a:r>
-              <a:t>Streamlit dashboard displaying threat severity cards, blast radius estimates, and authorization workflows.</a:t>
+              <a:t>Multi-provider AI (AMD Instinct ROCm vLLM / Ollama) with deterministic rule-based fallback and caching.</a:t>
             </a:r>
           </a:p>
         </p:txBody>
@@ -6200,7 +6200,7 @@
               </a:defRPr>
             </a:pPr>
             <a:r>
-              <a:t>Tier 4: Guardrail Remediation (remediation.py)</a:t>
+              <a:t>Tier 4: Auto-Refreshing Console (app.py)</a:t>
             </a:r>
           </a:p>
           <a:p>
@@ -6212,7 +6212,7 @@
               </a:defRPr>
             </a:pPr>
             <a:r>
-              <a:t>Boto3 execution engine enforcing default dry-run simulation and explicit human operator approval.</a:t>
+              <a:t>Near-real-time Streamlit dashboard with dual-mode switcher (Demo vs. Live) and 1-click Boto3 remediation.</a:t>
             </a:r>
           </a:p>
         </p:txBody>

</xml_diff>